<commit_message>
new version of the report
</commit_message>
<xml_diff>
--- a/report/chapters/methodology/pictures/methodology_figures_editable.pptx
+++ b/report/chapters/methodology/pictures/methodology_figures_editable.pptx
@@ -4690,7 +4690,7 @@
         </p:nvSpPr>
         <p:spPr>
           <a:xfrm>
-            <a:off x="973182" y="889363"/>
+            <a:off x="120695" y="222613"/>
             <a:ext cx="4000500" cy="342900"/>
           </a:xfrm>
           <a:prstGeom prst="rect">
@@ -4734,13 +4734,13 @@
             </a:extLst>
           </p:cNvPr>
           <p:cNvSpPr>
-            <a:spLocks noGrp="1"/>
-          </p:cNvSpPr>
-          <p:nvPr/>
-        </p:nvSpPr>
-        <p:spPr>
-          <a:xfrm>
-            <a:off x="6402432" y="889363"/>
+            <a:spLocks noGrp="1" noChangeAspect="1"/>
+          </p:cNvSpPr>
+          <p:nvPr/>
+        </p:nvSpPr>
+        <p:spPr>
+          <a:xfrm>
+            <a:off x="6402432" y="889360"/>
             <a:ext cx="4191000" cy="342900"/>
           </a:xfrm>
           <a:prstGeom prst="rect">
@@ -4790,7 +4790,7 @@
         </p:nvSpPr>
         <p:spPr>
           <a:xfrm>
-            <a:off x="1163682" y="1860913"/>
+            <a:off x="311195" y="1194163"/>
             <a:ext cx="495300" cy="495300"/>
           </a:xfrm>
           <a:prstGeom prst="ellipse">
@@ -4830,7 +4830,7 @@
         </p:nvSpPr>
         <p:spPr>
           <a:xfrm>
-            <a:off x="1220832" y="2013313"/>
+            <a:off x="368345" y="1346563"/>
             <a:ext cx="381000" cy="228600"/>
           </a:xfrm>
           <a:prstGeom prst="rect">
@@ -4880,7 +4880,7 @@
         </p:nvSpPr>
         <p:spPr>
           <a:xfrm>
-            <a:off x="1658982" y="4261213"/>
+            <a:off x="806495" y="3594463"/>
             <a:ext cx="495300" cy="495300"/>
           </a:xfrm>
           <a:prstGeom prst="ellipse">
@@ -4920,7 +4920,7 @@
         </p:nvSpPr>
         <p:spPr>
           <a:xfrm>
-            <a:off x="1716132" y="4413613"/>
+            <a:off x="863645" y="3746863"/>
             <a:ext cx="381000" cy="228600"/>
           </a:xfrm>
           <a:prstGeom prst="rect">
@@ -4970,7 +4970,7 @@
         </p:nvSpPr>
         <p:spPr>
           <a:xfrm>
-            <a:off x="2744832" y="2718163"/>
+            <a:off x="1892345" y="2051413"/>
             <a:ext cx="495300" cy="495300"/>
           </a:xfrm>
           <a:prstGeom prst="ellipse">
@@ -5010,7 +5010,7 @@
         </p:nvSpPr>
         <p:spPr>
           <a:xfrm>
-            <a:off x="2801982" y="2870563"/>
+            <a:off x="1949495" y="2203813"/>
             <a:ext cx="381000" cy="228600"/>
           </a:xfrm>
           <a:prstGeom prst="rect">
@@ -5060,7 +5060,7 @@
         </p:nvSpPr>
         <p:spPr>
           <a:xfrm>
-            <a:off x="3754482" y="4118338"/>
+            <a:off x="2901995" y="3451588"/>
             <a:ext cx="495300" cy="495300"/>
           </a:xfrm>
           <a:prstGeom prst="ellipse">
@@ -5100,7 +5100,7 @@
         </p:nvSpPr>
         <p:spPr>
           <a:xfrm>
-            <a:off x="3811632" y="4270738"/>
+            <a:off x="2959145" y="3603988"/>
             <a:ext cx="381000" cy="228600"/>
           </a:xfrm>
           <a:prstGeom prst="rect">
@@ -5150,7 +5150,7 @@
         </p:nvSpPr>
         <p:spPr>
           <a:xfrm>
-            <a:off x="4364082" y="1956163"/>
+            <a:off x="3511595" y="1289413"/>
             <a:ext cx="495300" cy="495300"/>
           </a:xfrm>
           <a:prstGeom prst="ellipse">
@@ -5190,7 +5190,7 @@
         </p:nvSpPr>
         <p:spPr>
           <a:xfrm>
-            <a:off x="4421232" y="2108563"/>
+            <a:off x="3568745" y="1441813"/>
             <a:ext cx="381000" cy="228600"/>
           </a:xfrm>
           <a:prstGeom prst="rect">
@@ -5240,7 +5240,7 @@
         </p:nvSpPr>
         <p:spPr>
           <a:xfrm>
-            <a:off x="5107032" y="3251563"/>
+            <a:off x="4254545" y="2584813"/>
             <a:ext cx="495300" cy="495300"/>
           </a:xfrm>
           <a:prstGeom prst="ellipse">
@@ -5280,7 +5280,7 @@
         </p:nvSpPr>
         <p:spPr>
           <a:xfrm>
-            <a:off x="5164182" y="3403963"/>
+            <a:off x="4311695" y="2737213"/>
             <a:ext cx="381000" cy="228600"/>
           </a:xfrm>
           <a:prstGeom prst="rect">
@@ -5325,7 +5325,7 @@
         </p:nvCxnSpPr>
         <p:spPr>
           <a:xfrm>
-            <a:off x="1586447" y="2283678"/>
+            <a:off x="733960" y="1616928"/>
             <a:ext cx="1230920" cy="507020"/>
           </a:xfrm>
           <a:prstGeom prst="straightConnector1">
@@ -5351,7 +5351,7 @@
         </p:nvCxnSpPr>
         <p:spPr>
           <a:xfrm flipV="1">
-            <a:off x="2154282" y="4365988"/>
+            <a:off x="1301795" y="3699238"/>
             <a:ext cx="1600200" cy="142875"/>
           </a:xfrm>
           <a:prstGeom prst="straightConnector1">
@@ -5377,7 +5377,7 @@
         </p:nvCxnSpPr>
         <p:spPr>
           <a:xfrm>
-            <a:off x="3167597" y="3140928"/>
+            <a:off x="2315110" y="2474178"/>
             <a:ext cx="659420" cy="1049945"/>
           </a:xfrm>
           <a:prstGeom prst="straightConnector1">
@@ -5403,7 +5403,7 @@
         </p:nvCxnSpPr>
         <p:spPr>
           <a:xfrm flipH="1">
-            <a:off x="4002132" y="2451463"/>
+            <a:off x="3149645" y="1784713"/>
             <a:ext cx="609600" cy="1666875"/>
           </a:xfrm>
           <a:prstGeom prst="straightConnector1">
@@ -5429,7 +5429,7 @@
         </p:nvCxnSpPr>
         <p:spPr>
           <a:xfrm>
-            <a:off x="4786847" y="2378928"/>
+            <a:off x="3934360" y="1712178"/>
             <a:ext cx="392720" cy="945170"/>
           </a:xfrm>
           <a:prstGeom prst="straightConnector1">
@@ -5454,13 +5454,13 @@
             </a:extLst>
           </p:cNvPr>
           <p:cNvSpPr>
-            <a:spLocks noGrp="1"/>
-          </p:cNvSpPr>
-          <p:nvPr/>
-        </p:nvSpPr>
-        <p:spPr>
-          <a:xfrm>
-            <a:off x="5926182" y="1832338"/>
+            <a:spLocks noGrp="1" noChangeAspect="1"/>
+          </p:cNvSpPr>
+          <p:nvPr/>
+        </p:nvSpPr>
+        <p:spPr>
+          <a:xfrm>
+            <a:off x="5926182" y="1832336"/>
             <a:ext cx="400050" cy="228600"/>
           </a:xfrm>
           <a:prstGeom prst="rect">
@@ -5504,13 +5504,13 @@
             </a:extLst>
           </p:cNvPr>
           <p:cNvSpPr>
-            <a:spLocks noGrp="1"/>
-          </p:cNvSpPr>
-          <p:nvPr/>
-        </p:nvSpPr>
-        <p:spPr>
-          <a:xfrm>
-            <a:off x="6535782" y="5270863"/>
+            <a:spLocks noGrp="1" noChangeAspect="1"/>
+          </p:cNvSpPr>
+          <p:nvPr/>
+        </p:nvSpPr>
+        <p:spPr>
+          <a:xfrm>
+            <a:off x="6535782" y="5270861"/>
             <a:ext cx="361950" cy="228600"/>
           </a:xfrm>
           <a:prstGeom prst="rect">
@@ -5554,14 +5554,14 @@
             </a:extLst>
           </p:cNvPr>
           <p:cNvSpPr>
-            <a:spLocks noGrp="1"/>
+            <a:spLocks noGrp="1" noChangeAspect="1"/>
           </p:cNvSpPr>
           <p:nvPr/>
         </p:nvSpPr>
         <p:spPr>
           <a:xfrm>
             <a:off x="6383382" y="1651363"/>
-            <a:ext cx="590550" cy="590550"/>
+            <a:ext cx="590550" cy="590551"/>
           </a:xfrm>
           <a:prstGeom prst="rect">
             <a:avLst/>
@@ -5592,13 +5592,13 @@
             </a:extLst>
           </p:cNvPr>
           <p:cNvSpPr>
-            <a:spLocks noGrp="1"/>
-          </p:cNvSpPr>
-          <p:nvPr/>
-        </p:nvSpPr>
-        <p:spPr>
-          <a:xfrm>
-            <a:off x="6564357" y="1822813"/>
+            <a:spLocks noGrp="1" noChangeAspect="1"/>
+          </p:cNvSpPr>
+          <p:nvPr/>
+        </p:nvSpPr>
+        <p:spPr>
+          <a:xfrm>
+            <a:off x="6564357" y="1822811"/>
             <a:ext cx="228600" cy="228600"/>
           </a:xfrm>
           <a:prstGeom prst="rect">
@@ -5642,14 +5642,14 @@
             </a:extLst>
           </p:cNvPr>
           <p:cNvSpPr>
-            <a:spLocks noGrp="1"/>
+            <a:spLocks noGrp="1" noChangeAspect="1"/>
           </p:cNvSpPr>
           <p:nvPr/>
         </p:nvSpPr>
         <p:spPr>
           <a:xfrm>
             <a:off x="6973932" y="1651363"/>
-            <a:ext cx="590550" cy="590550"/>
+            <a:ext cx="590550" cy="590551"/>
           </a:xfrm>
           <a:prstGeom prst="rect">
             <a:avLst/>
@@ -5680,13 +5680,13 @@
             </a:extLst>
           </p:cNvPr>
           <p:cNvSpPr>
-            <a:spLocks noGrp="1"/>
-          </p:cNvSpPr>
-          <p:nvPr/>
-        </p:nvSpPr>
-        <p:spPr>
-          <a:xfrm>
-            <a:off x="7154907" y="1822813"/>
+            <a:spLocks noGrp="1" noChangeAspect="1"/>
+          </p:cNvSpPr>
+          <p:nvPr/>
+        </p:nvSpPr>
+        <p:spPr>
+          <a:xfrm>
+            <a:off x="7154907" y="1822811"/>
             <a:ext cx="228600" cy="228600"/>
           </a:xfrm>
           <a:prstGeom prst="rect">
@@ -5730,14 +5730,14 @@
             </a:extLst>
           </p:cNvPr>
           <p:cNvSpPr>
-            <a:spLocks noGrp="1"/>
+            <a:spLocks noGrp="1" noChangeAspect="1"/>
           </p:cNvSpPr>
           <p:nvPr/>
         </p:nvSpPr>
         <p:spPr>
           <a:xfrm>
             <a:off x="7564482" y="1651363"/>
-            <a:ext cx="590550" cy="590550"/>
+            <a:ext cx="590550" cy="590551"/>
           </a:xfrm>
           <a:prstGeom prst="rect">
             <a:avLst/>
@@ -5768,13 +5768,13 @@
             </a:extLst>
           </p:cNvPr>
           <p:cNvSpPr>
-            <a:spLocks noGrp="1"/>
-          </p:cNvSpPr>
-          <p:nvPr/>
-        </p:nvSpPr>
-        <p:spPr>
-          <a:xfrm>
-            <a:off x="7745457" y="1822813"/>
+            <a:spLocks noGrp="1" noChangeAspect="1"/>
+          </p:cNvSpPr>
+          <p:nvPr/>
+        </p:nvSpPr>
+        <p:spPr>
+          <a:xfrm>
+            <a:off x="7745457" y="1822811"/>
             <a:ext cx="228600" cy="228600"/>
           </a:xfrm>
           <a:prstGeom prst="rect">
@@ -5818,14 +5818,14 @@
             </a:extLst>
           </p:cNvPr>
           <p:cNvSpPr>
-            <a:spLocks noGrp="1"/>
+            <a:spLocks noGrp="1" noChangeAspect="1"/>
           </p:cNvSpPr>
           <p:nvPr/>
         </p:nvSpPr>
         <p:spPr>
           <a:xfrm>
             <a:off x="8155032" y="1651363"/>
-            <a:ext cx="590550" cy="590550"/>
+            <a:ext cx="590550" cy="590551"/>
           </a:xfrm>
           <a:prstGeom prst="rect">
             <a:avLst/>
@@ -5856,13 +5856,13 @@
             </a:extLst>
           </p:cNvPr>
           <p:cNvSpPr>
-            <a:spLocks noGrp="1"/>
-          </p:cNvSpPr>
-          <p:nvPr/>
-        </p:nvSpPr>
-        <p:spPr>
-          <a:xfrm>
-            <a:off x="8336007" y="1822813"/>
+            <a:spLocks noGrp="1" noChangeAspect="1"/>
+          </p:cNvSpPr>
+          <p:nvPr/>
+        </p:nvSpPr>
+        <p:spPr>
+          <a:xfrm>
+            <a:off x="8336007" y="1822811"/>
             <a:ext cx="228600" cy="228600"/>
           </a:xfrm>
           <a:prstGeom prst="rect">
@@ -5906,14 +5906,14 @@
             </a:extLst>
           </p:cNvPr>
           <p:cNvSpPr>
-            <a:spLocks noGrp="1"/>
+            <a:spLocks noGrp="1" noChangeAspect="1"/>
           </p:cNvSpPr>
           <p:nvPr/>
         </p:nvSpPr>
         <p:spPr>
           <a:xfrm>
             <a:off x="8745582" y="1651363"/>
-            <a:ext cx="590550" cy="590550"/>
+            <a:ext cx="590550" cy="590551"/>
           </a:xfrm>
           <a:prstGeom prst="rect">
             <a:avLst/>
@@ -5944,13 +5944,13 @@
             </a:extLst>
           </p:cNvPr>
           <p:cNvSpPr>
-            <a:spLocks noGrp="1"/>
-          </p:cNvSpPr>
-          <p:nvPr/>
-        </p:nvSpPr>
-        <p:spPr>
-          <a:xfrm>
-            <a:off x="8926557" y="1822813"/>
+            <a:spLocks noGrp="1" noChangeAspect="1"/>
+          </p:cNvSpPr>
+          <p:nvPr/>
+        </p:nvSpPr>
+        <p:spPr>
+          <a:xfrm>
+            <a:off x="8926557" y="1822811"/>
             <a:ext cx="228600" cy="228600"/>
           </a:xfrm>
           <a:prstGeom prst="rect">
@@ -5994,14 +5994,14 @@
             </a:extLst>
           </p:cNvPr>
           <p:cNvSpPr>
-            <a:spLocks noGrp="1"/>
+            <a:spLocks noGrp="1" noChangeAspect="1"/>
           </p:cNvSpPr>
           <p:nvPr/>
         </p:nvSpPr>
         <p:spPr>
           <a:xfrm>
             <a:off x="9336132" y="1651363"/>
-            <a:ext cx="590550" cy="590550"/>
+            <a:ext cx="590550" cy="590551"/>
           </a:xfrm>
           <a:prstGeom prst="rect">
             <a:avLst/>
@@ -6032,13 +6032,13 @@
             </a:extLst>
           </p:cNvPr>
           <p:cNvSpPr>
-            <a:spLocks noGrp="1"/>
-          </p:cNvSpPr>
-          <p:nvPr/>
-        </p:nvSpPr>
-        <p:spPr>
-          <a:xfrm>
-            <a:off x="9517107" y="1822813"/>
+            <a:spLocks noGrp="1" noChangeAspect="1"/>
+          </p:cNvSpPr>
+          <p:nvPr/>
+        </p:nvSpPr>
+        <p:spPr>
+          <a:xfrm>
+            <a:off x="9517107" y="1822811"/>
             <a:ext cx="228600" cy="228600"/>
           </a:xfrm>
           <a:prstGeom prst="rect">
@@ -6082,13 +6082,13 @@
             </a:extLst>
           </p:cNvPr>
           <p:cNvSpPr>
-            <a:spLocks noGrp="1"/>
-          </p:cNvSpPr>
-          <p:nvPr/>
-        </p:nvSpPr>
-        <p:spPr>
-          <a:xfrm>
-            <a:off x="5926182" y="2422888"/>
+            <a:spLocks noGrp="1" noChangeAspect="1"/>
+          </p:cNvSpPr>
+          <p:nvPr/>
+        </p:nvSpPr>
+        <p:spPr>
+          <a:xfrm>
+            <a:off x="5926182" y="2422886"/>
             <a:ext cx="400050" cy="228600"/>
           </a:xfrm>
           <a:prstGeom prst="rect">
@@ -6132,13 +6132,13 @@
             </a:extLst>
           </p:cNvPr>
           <p:cNvSpPr>
-            <a:spLocks noGrp="1"/>
-          </p:cNvSpPr>
-          <p:nvPr/>
-        </p:nvSpPr>
-        <p:spPr>
-          <a:xfrm>
-            <a:off x="7126332" y="5270863"/>
+            <a:spLocks noGrp="1" noChangeAspect="1"/>
+          </p:cNvSpPr>
+          <p:nvPr/>
+        </p:nvSpPr>
+        <p:spPr>
+          <a:xfrm>
+            <a:off x="7126332" y="5270861"/>
             <a:ext cx="361950" cy="228600"/>
           </a:xfrm>
           <a:prstGeom prst="rect">
@@ -6182,14 +6182,14 @@
             </a:extLst>
           </p:cNvPr>
           <p:cNvSpPr>
-            <a:spLocks noGrp="1"/>
+            <a:spLocks noGrp="1" noChangeAspect="1"/>
           </p:cNvSpPr>
           <p:nvPr/>
         </p:nvSpPr>
         <p:spPr>
           <a:xfrm>
             <a:off x="6383382" y="2241913"/>
-            <a:ext cx="590550" cy="590550"/>
+            <a:ext cx="590550" cy="590551"/>
           </a:xfrm>
           <a:prstGeom prst="rect">
             <a:avLst/>
@@ -6220,13 +6220,13 @@
             </a:extLst>
           </p:cNvPr>
           <p:cNvSpPr>
-            <a:spLocks noGrp="1"/>
-          </p:cNvSpPr>
-          <p:nvPr/>
-        </p:nvSpPr>
-        <p:spPr>
-          <a:xfrm>
-            <a:off x="6564357" y="2413363"/>
+            <a:spLocks noGrp="1" noChangeAspect="1"/>
+          </p:cNvSpPr>
+          <p:nvPr/>
+        </p:nvSpPr>
+        <p:spPr>
+          <a:xfrm>
+            <a:off x="6564357" y="2413361"/>
             <a:ext cx="228600" cy="228600"/>
           </a:xfrm>
           <a:prstGeom prst="rect">
@@ -6270,14 +6270,14 @@
             </a:extLst>
           </p:cNvPr>
           <p:cNvSpPr>
-            <a:spLocks noGrp="1"/>
+            <a:spLocks noGrp="1" noChangeAspect="1"/>
           </p:cNvSpPr>
           <p:nvPr/>
         </p:nvSpPr>
         <p:spPr>
           <a:xfrm>
             <a:off x="6973932" y="2241913"/>
-            <a:ext cx="590550" cy="590550"/>
+            <a:ext cx="590550" cy="590551"/>
           </a:xfrm>
           <a:prstGeom prst="rect">
             <a:avLst/>
@@ -6308,13 +6308,13 @@
             </a:extLst>
           </p:cNvPr>
           <p:cNvSpPr>
-            <a:spLocks noGrp="1"/>
-          </p:cNvSpPr>
-          <p:nvPr/>
-        </p:nvSpPr>
-        <p:spPr>
-          <a:xfrm>
-            <a:off x="7154907" y="2413363"/>
+            <a:spLocks noGrp="1" noChangeAspect="1"/>
+          </p:cNvSpPr>
+          <p:nvPr/>
+        </p:nvSpPr>
+        <p:spPr>
+          <a:xfrm>
+            <a:off x="7154907" y="2413361"/>
             <a:ext cx="228600" cy="228600"/>
           </a:xfrm>
           <a:prstGeom prst="rect">
@@ -6358,14 +6358,14 @@
             </a:extLst>
           </p:cNvPr>
           <p:cNvSpPr>
-            <a:spLocks noGrp="1"/>
+            <a:spLocks noGrp="1" noChangeAspect="1"/>
           </p:cNvSpPr>
           <p:nvPr/>
         </p:nvSpPr>
         <p:spPr>
           <a:xfrm>
             <a:off x="7564482" y="2241913"/>
-            <a:ext cx="590550" cy="590550"/>
+            <a:ext cx="590550" cy="590551"/>
           </a:xfrm>
           <a:prstGeom prst="rect">
             <a:avLst/>
@@ -6396,13 +6396,13 @@
             </a:extLst>
           </p:cNvPr>
           <p:cNvSpPr>
-            <a:spLocks noGrp="1"/>
-          </p:cNvSpPr>
-          <p:nvPr/>
-        </p:nvSpPr>
-        <p:spPr>
-          <a:xfrm>
-            <a:off x="7745457" y="2413363"/>
+            <a:spLocks noGrp="1" noChangeAspect="1"/>
+          </p:cNvSpPr>
+          <p:nvPr/>
+        </p:nvSpPr>
+        <p:spPr>
+          <a:xfrm>
+            <a:off x="7745457" y="2413361"/>
             <a:ext cx="228600" cy="228600"/>
           </a:xfrm>
           <a:prstGeom prst="rect">
@@ -6446,14 +6446,14 @@
             </a:extLst>
           </p:cNvPr>
           <p:cNvSpPr>
-            <a:spLocks noGrp="1"/>
+            <a:spLocks noGrp="1" noChangeAspect="1"/>
           </p:cNvSpPr>
           <p:nvPr/>
         </p:nvSpPr>
         <p:spPr>
           <a:xfrm>
             <a:off x="8155032" y="2241913"/>
-            <a:ext cx="590550" cy="590550"/>
+            <a:ext cx="590550" cy="590551"/>
           </a:xfrm>
           <a:prstGeom prst="rect">
             <a:avLst/>
@@ -6484,13 +6484,13 @@
             </a:extLst>
           </p:cNvPr>
           <p:cNvSpPr>
-            <a:spLocks noGrp="1"/>
-          </p:cNvSpPr>
-          <p:nvPr/>
-        </p:nvSpPr>
-        <p:spPr>
-          <a:xfrm>
-            <a:off x="8336007" y="2413363"/>
+            <a:spLocks noGrp="1" noChangeAspect="1"/>
+          </p:cNvSpPr>
+          <p:nvPr/>
+        </p:nvSpPr>
+        <p:spPr>
+          <a:xfrm>
+            <a:off x="8336007" y="2413361"/>
             <a:ext cx="228600" cy="228600"/>
           </a:xfrm>
           <a:prstGeom prst="rect">
@@ -6534,14 +6534,14 @@
             </a:extLst>
           </p:cNvPr>
           <p:cNvSpPr>
-            <a:spLocks noGrp="1"/>
+            <a:spLocks noGrp="1" noChangeAspect="1"/>
           </p:cNvSpPr>
           <p:nvPr/>
         </p:nvSpPr>
         <p:spPr>
           <a:xfrm>
             <a:off x="8745582" y="2241913"/>
-            <a:ext cx="590550" cy="590550"/>
+            <a:ext cx="590550" cy="590551"/>
           </a:xfrm>
           <a:prstGeom prst="rect">
             <a:avLst/>
@@ -6572,13 +6572,13 @@
             </a:extLst>
           </p:cNvPr>
           <p:cNvSpPr>
-            <a:spLocks noGrp="1"/>
-          </p:cNvSpPr>
-          <p:nvPr/>
-        </p:nvSpPr>
-        <p:spPr>
-          <a:xfrm>
-            <a:off x="8926557" y="2413363"/>
+            <a:spLocks noGrp="1" noChangeAspect="1"/>
+          </p:cNvSpPr>
+          <p:nvPr/>
+        </p:nvSpPr>
+        <p:spPr>
+          <a:xfrm>
+            <a:off x="8926557" y="2413361"/>
             <a:ext cx="228600" cy="228600"/>
           </a:xfrm>
           <a:prstGeom prst="rect">
@@ -6622,14 +6622,14 @@
             </a:extLst>
           </p:cNvPr>
           <p:cNvSpPr>
-            <a:spLocks noGrp="1"/>
+            <a:spLocks noGrp="1" noChangeAspect="1"/>
           </p:cNvSpPr>
           <p:nvPr/>
         </p:nvSpPr>
         <p:spPr>
           <a:xfrm>
             <a:off x="9336132" y="2241913"/>
-            <a:ext cx="590550" cy="590550"/>
+            <a:ext cx="590550" cy="590551"/>
           </a:xfrm>
           <a:prstGeom prst="rect">
             <a:avLst/>
@@ -6660,13 +6660,13 @@
             </a:extLst>
           </p:cNvPr>
           <p:cNvSpPr>
-            <a:spLocks noGrp="1"/>
-          </p:cNvSpPr>
-          <p:nvPr/>
-        </p:nvSpPr>
-        <p:spPr>
-          <a:xfrm>
-            <a:off x="9517107" y="2413363"/>
+            <a:spLocks noGrp="1" noChangeAspect="1"/>
+          </p:cNvSpPr>
+          <p:nvPr/>
+        </p:nvSpPr>
+        <p:spPr>
+          <a:xfrm>
+            <a:off x="9517107" y="2413361"/>
             <a:ext cx="228600" cy="228600"/>
           </a:xfrm>
           <a:prstGeom prst="rect">
@@ -6710,13 +6710,13 @@
             </a:extLst>
           </p:cNvPr>
           <p:cNvSpPr>
-            <a:spLocks noGrp="1"/>
-          </p:cNvSpPr>
-          <p:nvPr/>
-        </p:nvSpPr>
-        <p:spPr>
-          <a:xfrm>
-            <a:off x="5926182" y="3013438"/>
+            <a:spLocks noGrp="1" noChangeAspect="1"/>
+          </p:cNvSpPr>
+          <p:nvPr/>
+        </p:nvSpPr>
+        <p:spPr>
+          <a:xfrm>
+            <a:off x="5926182" y="3013436"/>
             <a:ext cx="400050" cy="228600"/>
           </a:xfrm>
           <a:prstGeom prst="rect">
@@ -6760,13 +6760,13 @@
             </a:extLst>
           </p:cNvPr>
           <p:cNvSpPr>
-            <a:spLocks noGrp="1"/>
-          </p:cNvSpPr>
-          <p:nvPr/>
-        </p:nvSpPr>
-        <p:spPr>
-          <a:xfrm>
-            <a:off x="7716882" y="5270863"/>
+            <a:spLocks noGrp="1" noChangeAspect="1"/>
+          </p:cNvSpPr>
+          <p:nvPr/>
+        </p:nvSpPr>
+        <p:spPr>
+          <a:xfrm>
+            <a:off x="7716882" y="5270861"/>
             <a:ext cx="361950" cy="228600"/>
           </a:xfrm>
           <a:prstGeom prst="rect">
@@ -6810,14 +6810,14 @@
             </a:extLst>
           </p:cNvPr>
           <p:cNvSpPr>
-            <a:spLocks noGrp="1"/>
+            <a:spLocks noGrp="1" noChangeAspect="1"/>
           </p:cNvSpPr>
           <p:nvPr/>
         </p:nvSpPr>
         <p:spPr>
           <a:xfrm>
             <a:off x="6383382" y="2832463"/>
-            <a:ext cx="590550" cy="590550"/>
+            <a:ext cx="590550" cy="590551"/>
           </a:xfrm>
           <a:prstGeom prst="rect">
             <a:avLst/>
@@ -6848,13 +6848,13 @@
             </a:extLst>
           </p:cNvPr>
           <p:cNvSpPr>
-            <a:spLocks noGrp="1"/>
-          </p:cNvSpPr>
-          <p:nvPr/>
-        </p:nvSpPr>
-        <p:spPr>
-          <a:xfrm>
-            <a:off x="6564357" y="3003913"/>
+            <a:spLocks noGrp="1" noChangeAspect="1"/>
+          </p:cNvSpPr>
+          <p:nvPr/>
+        </p:nvSpPr>
+        <p:spPr>
+          <a:xfrm>
+            <a:off x="6564357" y="3003911"/>
             <a:ext cx="228600" cy="228600"/>
           </a:xfrm>
           <a:prstGeom prst="rect">
@@ -6898,14 +6898,14 @@
             </a:extLst>
           </p:cNvPr>
           <p:cNvSpPr>
-            <a:spLocks noGrp="1"/>
+            <a:spLocks noGrp="1" noChangeAspect="1"/>
           </p:cNvSpPr>
           <p:nvPr/>
         </p:nvSpPr>
         <p:spPr>
           <a:xfrm>
             <a:off x="6973932" y="2832463"/>
-            <a:ext cx="590550" cy="590550"/>
+            <a:ext cx="590550" cy="590551"/>
           </a:xfrm>
           <a:prstGeom prst="rect">
             <a:avLst/>
@@ -6936,13 +6936,13 @@
             </a:extLst>
           </p:cNvPr>
           <p:cNvSpPr>
-            <a:spLocks noGrp="1"/>
-          </p:cNvSpPr>
-          <p:nvPr/>
-        </p:nvSpPr>
-        <p:spPr>
-          <a:xfrm>
-            <a:off x="7154907" y="3003913"/>
+            <a:spLocks noGrp="1" noChangeAspect="1"/>
+          </p:cNvSpPr>
+          <p:nvPr/>
+        </p:nvSpPr>
+        <p:spPr>
+          <a:xfrm>
+            <a:off x="7154907" y="3003911"/>
             <a:ext cx="228600" cy="228600"/>
           </a:xfrm>
           <a:prstGeom prst="rect">
@@ -6986,14 +6986,14 @@
             </a:extLst>
           </p:cNvPr>
           <p:cNvSpPr>
-            <a:spLocks noGrp="1"/>
+            <a:spLocks noGrp="1" noChangeAspect="1"/>
           </p:cNvSpPr>
           <p:nvPr/>
         </p:nvSpPr>
         <p:spPr>
           <a:xfrm>
             <a:off x="7564482" y="2832463"/>
-            <a:ext cx="590550" cy="590550"/>
+            <a:ext cx="590550" cy="590551"/>
           </a:xfrm>
           <a:prstGeom prst="rect">
             <a:avLst/>
@@ -7024,13 +7024,13 @@
             </a:extLst>
           </p:cNvPr>
           <p:cNvSpPr>
-            <a:spLocks noGrp="1"/>
-          </p:cNvSpPr>
-          <p:nvPr/>
-        </p:nvSpPr>
-        <p:spPr>
-          <a:xfrm>
-            <a:off x="7745457" y="3003913"/>
+            <a:spLocks noGrp="1" noChangeAspect="1"/>
+          </p:cNvSpPr>
+          <p:nvPr/>
+        </p:nvSpPr>
+        <p:spPr>
+          <a:xfrm>
+            <a:off x="7745457" y="3003911"/>
             <a:ext cx="228600" cy="228600"/>
           </a:xfrm>
           <a:prstGeom prst="rect">
@@ -7074,14 +7074,14 @@
             </a:extLst>
           </p:cNvPr>
           <p:cNvSpPr>
-            <a:spLocks noGrp="1"/>
+            <a:spLocks noGrp="1" noChangeAspect="1"/>
           </p:cNvSpPr>
           <p:nvPr/>
         </p:nvSpPr>
         <p:spPr>
           <a:xfrm>
             <a:off x="8155032" y="2832463"/>
-            <a:ext cx="590550" cy="590550"/>
+            <a:ext cx="590550" cy="590551"/>
           </a:xfrm>
           <a:prstGeom prst="rect">
             <a:avLst/>
@@ -7112,13 +7112,13 @@
             </a:extLst>
           </p:cNvPr>
           <p:cNvSpPr>
-            <a:spLocks noGrp="1"/>
-          </p:cNvSpPr>
-          <p:nvPr/>
-        </p:nvSpPr>
-        <p:spPr>
-          <a:xfrm>
-            <a:off x="8336007" y="3003913"/>
+            <a:spLocks noGrp="1" noChangeAspect="1"/>
+          </p:cNvSpPr>
+          <p:nvPr/>
+        </p:nvSpPr>
+        <p:spPr>
+          <a:xfrm>
+            <a:off x="8336007" y="3003911"/>
             <a:ext cx="228600" cy="228600"/>
           </a:xfrm>
           <a:prstGeom prst="rect">
@@ -7162,14 +7162,14 @@
             </a:extLst>
           </p:cNvPr>
           <p:cNvSpPr>
-            <a:spLocks noGrp="1"/>
+            <a:spLocks noGrp="1" noChangeAspect="1"/>
           </p:cNvSpPr>
           <p:nvPr/>
         </p:nvSpPr>
         <p:spPr>
           <a:xfrm>
             <a:off x="8745582" y="2832463"/>
-            <a:ext cx="590550" cy="590550"/>
+            <a:ext cx="590550" cy="590551"/>
           </a:xfrm>
           <a:prstGeom prst="rect">
             <a:avLst/>
@@ -7200,13 +7200,13 @@
             </a:extLst>
           </p:cNvPr>
           <p:cNvSpPr>
-            <a:spLocks noGrp="1"/>
-          </p:cNvSpPr>
-          <p:nvPr/>
-        </p:nvSpPr>
-        <p:spPr>
-          <a:xfrm>
-            <a:off x="8926557" y="3003913"/>
+            <a:spLocks noGrp="1" noChangeAspect="1"/>
+          </p:cNvSpPr>
+          <p:nvPr/>
+        </p:nvSpPr>
+        <p:spPr>
+          <a:xfrm>
+            <a:off x="8926557" y="3003911"/>
             <a:ext cx="228600" cy="228600"/>
           </a:xfrm>
           <a:prstGeom prst="rect">
@@ -7250,14 +7250,14 @@
             </a:extLst>
           </p:cNvPr>
           <p:cNvSpPr>
-            <a:spLocks noGrp="1"/>
+            <a:spLocks noGrp="1" noChangeAspect="1"/>
           </p:cNvSpPr>
           <p:nvPr/>
         </p:nvSpPr>
         <p:spPr>
           <a:xfrm>
             <a:off x="9336132" y="2832463"/>
-            <a:ext cx="590550" cy="590550"/>
+            <a:ext cx="590550" cy="590551"/>
           </a:xfrm>
           <a:prstGeom prst="rect">
             <a:avLst/>
@@ -7288,13 +7288,13 @@
             </a:extLst>
           </p:cNvPr>
           <p:cNvSpPr>
-            <a:spLocks noGrp="1"/>
-          </p:cNvSpPr>
-          <p:nvPr/>
-        </p:nvSpPr>
-        <p:spPr>
-          <a:xfrm>
-            <a:off x="9517107" y="3003913"/>
+            <a:spLocks noGrp="1" noChangeAspect="1"/>
+          </p:cNvSpPr>
+          <p:nvPr/>
+        </p:nvSpPr>
+        <p:spPr>
+          <a:xfrm>
+            <a:off x="9517107" y="3003911"/>
             <a:ext cx="228600" cy="228600"/>
           </a:xfrm>
           <a:prstGeom prst="rect">
@@ -7338,13 +7338,13 @@
             </a:extLst>
           </p:cNvPr>
           <p:cNvSpPr>
-            <a:spLocks noGrp="1"/>
-          </p:cNvSpPr>
-          <p:nvPr/>
-        </p:nvSpPr>
-        <p:spPr>
-          <a:xfrm>
-            <a:off x="5926182" y="3603988"/>
+            <a:spLocks noGrp="1" noChangeAspect="1"/>
+          </p:cNvSpPr>
+          <p:nvPr/>
+        </p:nvSpPr>
+        <p:spPr>
+          <a:xfrm>
+            <a:off x="5926182" y="3603986"/>
             <a:ext cx="400050" cy="228600"/>
           </a:xfrm>
           <a:prstGeom prst="rect">
@@ -7388,13 +7388,13 @@
             </a:extLst>
           </p:cNvPr>
           <p:cNvSpPr>
-            <a:spLocks noGrp="1"/>
-          </p:cNvSpPr>
-          <p:nvPr/>
-        </p:nvSpPr>
-        <p:spPr>
-          <a:xfrm>
-            <a:off x="8307432" y="5270863"/>
+            <a:spLocks noGrp="1" noChangeAspect="1"/>
+          </p:cNvSpPr>
+          <p:nvPr/>
+        </p:nvSpPr>
+        <p:spPr>
+          <a:xfrm>
+            <a:off x="8307432" y="5270861"/>
             <a:ext cx="361950" cy="228600"/>
           </a:xfrm>
           <a:prstGeom prst="rect">
@@ -7438,14 +7438,14 @@
             </a:extLst>
           </p:cNvPr>
           <p:cNvSpPr>
-            <a:spLocks noGrp="1"/>
+            <a:spLocks noGrp="1" noChangeAspect="1"/>
           </p:cNvSpPr>
           <p:nvPr/>
         </p:nvSpPr>
         <p:spPr>
           <a:xfrm>
             <a:off x="6383382" y="3423013"/>
-            <a:ext cx="590550" cy="590550"/>
+            <a:ext cx="590550" cy="590551"/>
           </a:xfrm>
           <a:prstGeom prst="rect">
             <a:avLst/>
@@ -7476,13 +7476,13 @@
             </a:extLst>
           </p:cNvPr>
           <p:cNvSpPr>
-            <a:spLocks noGrp="1"/>
-          </p:cNvSpPr>
-          <p:nvPr/>
-        </p:nvSpPr>
-        <p:spPr>
-          <a:xfrm>
-            <a:off x="6564357" y="3594463"/>
+            <a:spLocks noGrp="1" noChangeAspect="1"/>
+          </p:cNvSpPr>
+          <p:nvPr/>
+        </p:nvSpPr>
+        <p:spPr>
+          <a:xfrm>
+            <a:off x="6564357" y="3594461"/>
             <a:ext cx="228600" cy="228600"/>
           </a:xfrm>
           <a:prstGeom prst="rect">
@@ -7526,14 +7526,14 @@
             </a:extLst>
           </p:cNvPr>
           <p:cNvSpPr>
-            <a:spLocks noGrp="1"/>
+            <a:spLocks noGrp="1" noChangeAspect="1"/>
           </p:cNvSpPr>
           <p:nvPr/>
         </p:nvSpPr>
         <p:spPr>
           <a:xfrm>
             <a:off x="6973932" y="3423013"/>
-            <a:ext cx="590550" cy="590550"/>
+            <a:ext cx="590550" cy="590551"/>
           </a:xfrm>
           <a:prstGeom prst="rect">
             <a:avLst/>
@@ -7564,13 +7564,13 @@
             </a:extLst>
           </p:cNvPr>
           <p:cNvSpPr>
-            <a:spLocks noGrp="1"/>
-          </p:cNvSpPr>
-          <p:nvPr/>
-        </p:nvSpPr>
-        <p:spPr>
-          <a:xfrm>
-            <a:off x="7154907" y="3594463"/>
+            <a:spLocks noGrp="1" noChangeAspect="1"/>
+          </p:cNvSpPr>
+          <p:nvPr/>
+        </p:nvSpPr>
+        <p:spPr>
+          <a:xfrm>
+            <a:off x="7154907" y="3594461"/>
             <a:ext cx="228600" cy="228600"/>
           </a:xfrm>
           <a:prstGeom prst="rect">
@@ -7614,14 +7614,14 @@
             </a:extLst>
           </p:cNvPr>
           <p:cNvSpPr>
-            <a:spLocks noGrp="1"/>
+            <a:spLocks noGrp="1" noChangeAspect="1"/>
           </p:cNvSpPr>
           <p:nvPr/>
         </p:nvSpPr>
         <p:spPr>
           <a:xfrm>
             <a:off x="7564482" y="3423013"/>
-            <a:ext cx="590550" cy="590550"/>
+            <a:ext cx="590550" cy="590551"/>
           </a:xfrm>
           <a:prstGeom prst="rect">
             <a:avLst/>
@@ -7652,13 +7652,13 @@
             </a:extLst>
           </p:cNvPr>
           <p:cNvSpPr>
-            <a:spLocks noGrp="1"/>
-          </p:cNvSpPr>
-          <p:nvPr/>
-        </p:nvSpPr>
-        <p:spPr>
-          <a:xfrm>
-            <a:off x="7745457" y="3594463"/>
+            <a:spLocks noGrp="1" noChangeAspect="1"/>
+          </p:cNvSpPr>
+          <p:nvPr/>
+        </p:nvSpPr>
+        <p:spPr>
+          <a:xfrm>
+            <a:off x="7745457" y="3594461"/>
             <a:ext cx="228600" cy="228600"/>
           </a:xfrm>
           <a:prstGeom prst="rect">
@@ -7702,14 +7702,14 @@
             </a:extLst>
           </p:cNvPr>
           <p:cNvSpPr>
-            <a:spLocks noGrp="1"/>
+            <a:spLocks noGrp="1" noChangeAspect="1"/>
           </p:cNvSpPr>
           <p:nvPr/>
         </p:nvSpPr>
         <p:spPr>
           <a:xfrm>
             <a:off x="8155032" y="3423013"/>
-            <a:ext cx="590550" cy="590550"/>
+            <a:ext cx="590550" cy="590551"/>
           </a:xfrm>
           <a:prstGeom prst="rect">
             <a:avLst/>
@@ -7740,13 +7740,13 @@
             </a:extLst>
           </p:cNvPr>
           <p:cNvSpPr>
-            <a:spLocks noGrp="1"/>
-          </p:cNvSpPr>
-          <p:nvPr/>
-        </p:nvSpPr>
-        <p:spPr>
-          <a:xfrm>
-            <a:off x="8336007" y="3594463"/>
+            <a:spLocks noGrp="1" noChangeAspect="1"/>
+          </p:cNvSpPr>
+          <p:nvPr/>
+        </p:nvSpPr>
+        <p:spPr>
+          <a:xfrm>
+            <a:off x="8336007" y="3594461"/>
             <a:ext cx="228600" cy="228600"/>
           </a:xfrm>
           <a:prstGeom prst="rect">
@@ -7790,14 +7790,14 @@
             </a:extLst>
           </p:cNvPr>
           <p:cNvSpPr>
-            <a:spLocks noGrp="1"/>
+            <a:spLocks noGrp="1" noChangeAspect="1"/>
           </p:cNvSpPr>
           <p:nvPr/>
         </p:nvSpPr>
         <p:spPr>
           <a:xfrm>
             <a:off x="8745582" y="3423013"/>
-            <a:ext cx="590550" cy="590550"/>
+            <a:ext cx="590550" cy="590551"/>
           </a:xfrm>
           <a:prstGeom prst="rect">
             <a:avLst/>
@@ -7828,13 +7828,13 @@
             </a:extLst>
           </p:cNvPr>
           <p:cNvSpPr>
-            <a:spLocks noGrp="1"/>
-          </p:cNvSpPr>
-          <p:nvPr/>
-        </p:nvSpPr>
-        <p:spPr>
-          <a:xfrm>
-            <a:off x="8926557" y="3594463"/>
+            <a:spLocks noGrp="1" noChangeAspect="1"/>
+          </p:cNvSpPr>
+          <p:nvPr/>
+        </p:nvSpPr>
+        <p:spPr>
+          <a:xfrm>
+            <a:off x="8926557" y="3594461"/>
             <a:ext cx="228600" cy="228600"/>
           </a:xfrm>
           <a:prstGeom prst="rect">
@@ -7878,14 +7878,14 @@
             </a:extLst>
           </p:cNvPr>
           <p:cNvSpPr>
-            <a:spLocks noGrp="1"/>
+            <a:spLocks noGrp="1" noChangeAspect="1"/>
           </p:cNvSpPr>
           <p:nvPr/>
         </p:nvSpPr>
         <p:spPr>
           <a:xfrm>
             <a:off x="9336132" y="3423013"/>
-            <a:ext cx="590550" cy="590550"/>
+            <a:ext cx="590550" cy="590551"/>
           </a:xfrm>
           <a:prstGeom prst="rect">
             <a:avLst/>
@@ -7916,13 +7916,13 @@
             </a:extLst>
           </p:cNvPr>
           <p:cNvSpPr>
-            <a:spLocks noGrp="1"/>
-          </p:cNvSpPr>
-          <p:nvPr/>
-        </p:nvSpPr>
-        <p:spPr>
-          <a:xfrm>
-            <a:off x="9517107" y="3594463"/>
+            <a:spLocks noGrp="1" noChangeAspect="1"/>
+          </p:cNvSpPr>
+          <p:nvPr/>
+        </p:nvSpPr>
+        <p:spPr>
+          <a:xfrm>
+            <a:off x="9517107" y="3594461"/>
             <a:ext cx="228600" cy="228600"/>
           </a:xfrm>
           <a:prstGeom prst="rect">
@@ -7966,13 +7966,13 @@
             </a:extLst>
           </p:cNvPr>
           <p:cNvSpPr>
-            <a:spLocks noGrp="1"/>
-          </p:cNvSpPr>
-          <p:nvPr/>
-        </p:nvSpPr>
-        <p:spPr>
-          <a:xfrm>
-            <a:off x="5926182" y="4194538"/>
+            <a:spLocks noGrp="1" noChangeAspect="1"/>
+          </p:cNvSpPr>
+          <p:nvPr/>
+        </p:nvSpPr>
+        <p:spPr>
+          <a:xfrm>
+            <a:off x="5926182" y="4194536"/>
             <a:ext cx="400050" cy="228600"/>
           </a:xfrm>
           <a:prstGeom prst="rect">
@@ -8016,13 +8016,13 @@
             </a:extLst>
           </p:cNvPr>
           <p:cNvSpPr>
-            <a:spLocks noGrp="1"/>
-          </p:cNvSpPr>
-          <p:nvPr/>
-        </p:nvSpPr>
-        <p:spPr>
-          <a:xfrm>
-            <a:off x="8897982" y="5270863"/>
+            <a:spLocks noGrp="1" noChangeAspect="1"/>
+          </p:cNvSpPr>
+          <p:nvPr/>
+        </p:nvSpPr>
+        <p:spPr>
+          <a:xfrm>
+            <a:off x="8897982" y="5270861"/>
             <a:ext cx="361950" cy="228600"/>
           </a:xfrm>
           <a:prstGeom prst="rect">
@@ -8066,14 +8066,14 @@
             </a:extLst>
           </p:cNvPr>
           <p:cNvSpPr>
-            <a:spLocks noGrp="1"/>
+            <a:spLocks noGrp="1" noChangeAspect="1"/>
           </p:cNvSpPr>
           <p:nvPr/>
         </p:nvSpPr>
         <p:spPr>
           <a:xfrm>
             <a:off x="6383382" y="4013563"/>
-            <a:ext cx="590550" cy="590550"/>
+            <a:ext cx="590550" cy="590551"/>
           </a:xfrm>
           <a:prstGeom prst="rect">
             <a:avLst/>
@@ -8104,13 +8104,13 @@
             </a:extLst>
           </p:cNvPr>
           <p:cNvSpPr>
-            <a:spLocks noGrp="1"/>
-          </p:cNvSpPr>
-          <p:nvPr/>
-        </p:nvSpPr>
-        <p:spPr>
-          <a:xfrm>
-            <a:off x="6564357" y="4185013"/>
+            <a:spLocks noGrp="1" noChangeAspect="1"/>
+          </p:cNvSpPr>
+          <p:nvPr/>
+        </p:nvSpPr>
+        <p:spPr>
+          <a:xfrm>
+            <a:off x="6564357" y="4185011"/>
             <a:ext cx="228600" cy="228600"/>
           </a:xfrm>
           <a:prstGeom prst="rect">
@@ -8154,14 +8154,14 @@
             </a:extLst>
           </p:cNvPr>
           <p:cNvSpPr>
-            <a:spLocks noGrp="1"/>
+            <a:spLocks noGrp="1" noChangeAspect="1"/>
           </p:cNvSpPr>
           <p:nvPr/>
         </p:nvSpPr>
         <p:spPr>
           <a:xfrm>
             <a:off x="6973932" y="4013563"/>
-            <a:ext cx="590550" cy="590550"/>
+            <a:ext cx="590550" cy="590551"/>
           </a:xfrm>
           <a:prstGeom prst="rect">
             <a:avLst/>
@@ -8192,13 +8192,13 @@
             </a:extLst>
           </p:cNvPr>
           <p:cNvSpPr>
-            <a:spLocks noGrp="1"/>
-          </p:cNvSpPr>
-          <p:nvPr/>
-        </p:nvSpPr>
-        <p:spPr>
-          <a:xfrm>
-            <a:off x="7154907" y="4185013"/>
+            <a:spLocks noGrp="1" noChangeAspect="1"/>
+          </p:cNvSpPr>
+          <p:nvPr/>
+        </p:nvSpPr>
+        <p:spPr>
+          <a:xfrm>
+            <a:off x="7154907" y="4185011"/>
             <a:ext cx="228600" cy="228600"/>
           </a:xfrm>
           <a:prstGeom prst="rect">
@@ -8242,14 +8242,14 @@
             </a:extLst>
           </p:cNvPr>
           <p:cNvSpPr>
-            <a:spLocks noGrp="1"/>
+            <a:spLocks noGrp="1" noChangeAspect="1"/>
           </p:cNvSpPr>
           <p:nvPr/>
         </p:nvSpPr>
         <p:spPr>
           <a:xfrm>
             <a:off x="7564482" y="4013563"/>
-            <a:ext cx="590550" cy="590550"/>
+            <a:ext cx="590550" cy="590551"/>
           </a:xfrm>
           <a:prstGeom prst="rect">
             <a:avLst/>
@@ -8280,13 +8280,13 @@
             </a:extLst>
           </p:cNvPr>
           <p:cNvSpPr>
-            <a:spLocks noGrp="1"/>
-          </p:cNvSpPr>
-          <p:nvPr/>
-        </p:nvSpPr>
-        <p:spPr>
-          <a:xfrm>
-            <a:off x="7745457" y="4185013"/>
+            <a:spLocks noGrp="1" noChangeAspect="1"/>
+          </p:cNvSpPr>
+          <p:nvPr/>
+        </p:nvSpPr>
+        <p:spPr>
+          <a:xfrm>
+            <a:off x="7745457" y="4185011"/>
             <a:ext cx="228600" cy="228600"/>
           </a:xfrm>
           <a:prstGeom prst="rect">
@@ -8330,14 +8330,14 @@
             </a:extLst>
           </p:cNvPr>
           <p:cNvSpPr>
-            <a:spLocks noGrp="1"/>
+            <a:spLocks noGrp="1" noChangeAspect="1"/>
           </p:cNvSpPr>
           <p:nvPr/>
         </p:nvSpPr>
         <p:spPr>
           <a:xfrm>
             <a:off x="8155032" y="4013563"/>
-            <a:ext cx="590550" cy="590550"/>
+            <a:ext cx="590550" cy="590551"/>
           </a:xfrm>
           <a:prstGeom prst="rect">
             <a:avLst/>
@@ -8368,13 +8368,13 @@
             </a:extLst>
           </p:cNvPr>
           <p:cNvSpPr>
-            <a:spLocks noGrp="1"/>
-          </p:cNvSpPr>
-          <p:nvPr/>
-        </p:nvSpPr>
-        <p:spPr>
-          <a:xfrm>
-            <a:off x="8336007" y="4185013"/>
+            <a:spLocks noGrp="1" noChangeAspect="1"/>
+          </p:cNvSpPr>
+          <p:nvPr/>
+        </p:nvSpPr>
+        <p:spPr>
+          <a:xfrm>
+            <a:off x="8336007" y="4185011"/>
             <a:ext cx="228600" cy="228600"/>
           </a:xfrm>
           <a:prstGeom prst="rect">
@@ -8418,14 +8418,14 @@
             </a:extLst>
           </p:cNvPr>
           <p:cNvSpPr>
-            <a:spLocks noGrp="1"/>
+            <a:spLocks noGrp="1" noChangeAspect="1"/>
           </p:cNvSpPr>
           <p:nvPr/>
         </p:nvSpPr>
         <p:spPr>
           <a:xfrm>
             <a:off x="8745582" y="4013563"/>
-            <a:ext cx="590550" cy="590550"/>
+            <a:ext cx="590550" cy="590551"/>
           </a:xfrm>
           <a:prstGeom prst="rect">
             <a:avLst/>
@@ -8456,13 +8456,13 @@
             </a:extLst>
           </p:cNvPr>
           <p:cNvSpPr>
-            <a:spLocks noGrp="1"/>
-          </p:cNvSpPr>
-          <p:nvPr/>
-        </p:nvSpPr>
-        <p:spPr>
-          <a:xfrm>
-            <a:off x="8926557" y="4185013"/>
+            <a:spLocks noGrp="1" noChangeAspect="1"/>
+          </p:cNvSpPr>
+          <p:nvPr/>
+        </p:nvSpPr>
+        <p:spPr>
+          <a:xfrm>
+            <a:off x="8926557" y="4185011"/>
             <a:ext cx="228600" cy="228600"/>
           </a:xfrm>
           <a:prstGeom prst="rect">
@@ -8506,14 +8506,14 @@
             </a:extLst>
           </p:cNvPr>
           <p:cNvSpPr>
-            <a:spLocks noGrp="1"/>
+            <a:spLocks noGrp="1" noChangeAspect="1"/>
           </p:cNvSpPr>
           <p:nvPr/>
         </p:nvSpPr>
         <p:spPr>
           <a:xfrm>
             <a:off x="9336132" y="4013563"/>
-            <a:ext cx="590550" cy="590550"/>
+            <a:ext cx="590550" cy="590551"/>
           </a:xfrm>
           <a:prstGeom prst="rect">
             <a:avLst/>
@@ -8544,13 +8544,13 @@
             </a:extLst>
           </p:cNvPr>
           <p:cNvSpPr>
-            <a:spLocks noGrp="1"/>
-          </p:cNvSpPr>
-          <p:nvPr/>
-        </p:nvSpPr>
-        <p:spPr>
-          <a:xfrm>
-            <a:off x="9517107" y="4185013"/>
+            <a:spLocks noGrp="1" noChangeAspect="1"/>
+          </p:cNvSpPr>
+          <p:nvPr/>
+        </p:nvSpPr>
+        <p:spPr>
+          <a:xfrm>
+            <a:off x="9517107" y="4185011"/>
             <a:ext cx="228600" cy="228600"/>
           </a:xfrm>
           <a:prstGeom prst="rect">
@@ -8594,13 +8594,13 @@
             </a:extLst>
           </p:cNvPr>
           <p:cNvSpPr>
-            <a:spLocks noGrp="1"/>
-          </p:cNvSpPr>
-          <p:nvPr/>
-        </p:nvSpPr>
-        <p:spPr>
-          <a:xfrm>
-            <a:off x="5926182" y="4785088"/>
+            <a:spLocks noGrp="1" noChangeAspect="1"/>
+          </p:cNvSpPr>
+          <p:nvPr/>
+        </p:nvSpPr>
+        <p:spPr>
+          <a:xfrm>
+            <a:off x="5926182" y="4785086"/>
             <a:ext cx="400050" cy="228600"/>
           </a:xfrm>
           <a:prstGeom prst="rect">
@@ -8644,13 +8644,13 @@
             </a:extLst>
           </p:cNvPr>
           <p:cNvSpPr>
-            <a:spLocks noGrp="1"/>
-          </p:cNvSpPr>
-          <p:nvPr/>
-        </p:nvSpPr>
-        <p:spPr>
-          <a:xfrm>
-            <a:off x="9488532" y="5270863"/>
+            <a:spLocks noGrp="1" noChangeAspect="1"/>
+          </p:cNvSpPr>
+          <p:nvPr/>
+        </p:nvSpPr>
+        <p:spPr>
+          <a:xfrm>
+            <a:off x="9488532" y="5270861"/>
             <a:ext cx="361950" cy="228600"/>
           </a:xfrm>
           <a:prstGeom prst="rect">
@@ -8694,14 +8694,14 @@
             </a:extLst>
           </p:cNvPr>
           <p:cNvSpPr>
-            <a:spLocks noGrp="1"/>
+            <a:spLocks noGrp="1" noChangeAspect="1"/>
           </p:cNvSpPr>
           <p:nvPr/>
         </p:nvSpPr>
         <p:spPr>
           <a:xfrm>
             <a:off x="6383382" y="4604113"/>
-            <a:ext cx="590550" cy="590550"/>
+            <a:ext cx="590550" cy="590551"/>
           </a:xfrm>
           <a:prstGeom prst="rect">
             <a:avLst/>
@@ -8732,13 +8732,13 @@
             </a:extLst>
           </p:cNvPr>
           <p:cNvSpPr>
-            <a:spLocks noGrp="1"/>
-          </p:cNvSpPr>
-          <p:nvPr/>
-        </p:nvSpPr>
-        <p:spPr>
-          <a:xfrm>
-            <a:off x="6564357" y="4775563"/>
+            <a:spLocks noGrp="1" noChangeAspect="1"/>
+          </p:cNvSpPr>
+          <p:nvPr/>
+        </p:nvSpPr>
+        <p:spPr>
+          <a:xfrm>
+            <a:off x="6564357" y="4775561"/>
             <a:ext cx="228600" cy="228600"/>
           </a:xfrm>
           <a:prstGeom prst="rect">
@@ -8782,14 +8782,14 @@
             </a:extLst>
           </p:cNvPr>
           <p:cNvSpPr>
-            <a:spLocks noGrp="1"/>
+            <a:spLocks noGrp="1" noChangeAspect="1"/>
           </p:cNvSpPr>
           <p:nvPr/>
         </p:nvSpPr>
         <p:spPr>
           <a:xfrm>
             <a:off x="6973932" y="4604113"/>
-            <a:ext cx="590550" cy="590550"/>
+            <a:ext cx="590550" cy="590551"/>
           </a:xfrm>
           <a:prstGeom prst="rect">
             <a:avLst/>
@@ -8820,13 +8820,13 @@
             </a:extLst>
           </p:cNvPr>
           <p:cNvSpPr>
-            <a:spLocks noGrp="1"/>
-          </p:cNvSpPr>
-          <p:nvPr/>
-        </p:nvSpPr>
-        <p:spPr>
-          <a:xfrm>
-            <a:off x="7154907" y="4775563"/>
+            <a:spLocks noGrp="1" noChangeAspect="1"/>
+          </p:cNvSpPr>
+          <p:nvPr/>
+        </p:nvSpPr>
+        <p:spPr>
+          <a:xfrm>
+            <a:off x="7154907" y="4775561"/>
             <a:ext cx="228600" cy="228600"/>
           </a:xfrm>
           <a:prstGeom prst="rect">
@@ -8870,14 +8870,14 @@
             </a:extLst>
           </p:cNvPr>
           <p:cNvSpPr>
-            <a:spLocks noGrp="1"/>
+            <a:spLocks noGrp="1" noChangeAspect="1"/>
           </p:cNvSpPr>
           <p:nvPr/>
         </p:nvSpPr>
         <p:spPr>
           <a:xfrm>
             <a:off x="7564482" y="4604113"/>
-            <a:ext cx="590550" cy="590550"/>
+            <a:ext cx="590550" cy="590551"/>
           </a:xfrm>
           <a:prstGeom prst="rect">
             <a:avLst/>
@@ -8908,13 +8908,13 @@
             </a:extLst>
           </p:cNvPr>
           <p:cNvSpPr>
-            <a:spLocks noGrp="1"/>
-          </p:cNvSpPr>
-          <p:nvPr/>
-        </p:nvSpPr>
-        <p:spPr>
-          <a:xfrm>
-            <a:off x="7745457" y="4775563"/>
+            <a:spLocks noGrp="1" noChangeAspect="1"/>
+          </p:cNvSpPr>
+          <p:nvPr/>
+        </p:nvSpPr>
+        <p:spPr>
+          <a:xfrm>
+            <a:off x="7745457" y="4775561"/>
             <a:ext cx="228600" cy="228600"/>
           </a:xfrm>
           <a:prstGeom prst="rect">
@@ -8958,14 +8958,14 @@
             </a:extLst>
           </p:cNvPr>
           <p:cNvSpPr>
-            <a:spLocks noGrp="1"/>
+            <a:spLocks noGrp="1" noChangeAspect="1"/>
           </p:cNvSpPr>
           <p:nvPr/>
         </p:nvSpPr>
         <p:spPr>
           <a:xfrm>
             <a:off x="8155032" y="4604113"/>
-            <a:ext cx="590550" cy="590550"/>
+            <a:ext cx="590550" cy="590551"/>
           </a:xfrm>
           <a:prstGeom prst="rect">
             <a:avLst/>
@@ -8996,13 +8996,13 @@
             </a:extLst>
           </p:cNvPr>
           <p:cNvSpPr>
-            <a:spLocks noGrp="1"/>
-          </p:cNvSpPr>
-          <p:nvPr/>
-        </p:nvSpPr>
-        <p:spPr>
-          <a:xfrm>
-            <a:off x="8336007" y="4775563"/>
+            <a:spLocks noGrp="1" noChangeAspect="1"/>
+          </p:cNvSpPr>
+          <p:nvPr/>
+        </p:nvSpPr>
+        <p:spPr>
+          <a:xfrm>
+            <a:off x="8336007" y="4775561"/>
             <a:ext cx="228600" cy="228600"/>
           </a:xfrm>
           <a:prstGeom prst="rect">
@@ -9046,14 +9046,14 @@
             </a:extLst>
           </p:cNvPr>
           <p:cNvSpPr>
-            <a:spLocks noGrp="1"/>
+            <a:spLocks noGrp="1" noChangeAspect="1"/>
           </p:cNvSpPr>
           <p:nvPr/>
         </p:nvSpPr>
         <p:spPr>
           <a:xfrm>
             <a:off x="8745582" y="4604113"/>
-            <a:ext cx="590550" cy="590550"/>
+            <a:ext cx="590550" cy="590551"/>
           </a:xfrm>
           <a:prstGeom prst="rect">
             <a:avLst/>
@@ -9084,13 +9084,13 @@
             </a:extLst>
           </p:cNvPr>
           <p:cNvSpPr>
-            <a:spLocks noGrp="1"/>
-          </p:cNvSpPr>
-          <p:nvPr/>
-        </p:nvSpPr>
-        <p:spPr>
-          <a:xfrm>
-            <a:off x="8926557" y="4775563"/>
+            <a:spLocks noGrp="1" noChangeAspect="1"/>
+          </p:cNvSpPr>
+          <p:nvPr/>
+        </p:nvSpPr>
+        <p:spPr>
+          <a:xfrm>
+            <a:off x="8926557" y="4775561"/>
             <a:ext cx="228600" cy="228600"/>
           </a:xfrm>
           <a:prstGeom prst="rect">
@@ -9134,14 +9134,14 @@
             </a:extLst>
           </p:cNvPr>
           <p:cNvSpPr>
-            <a:spLocks noGrp="1"/>
+            <a:spLocks noGrp="1" noChangeAspect="1"/>
           </p:cNvSpPr>
           <p:nvPr/>
         </p:nvSpPr>
         <p:spPr>
           <a:xfrm>
             <a:off x="9336132" y="4604113"/>
-            <a:ext cx="590550" cy="590550"/>
+            <a:ext cx="590550" cy="590551"/>
           </a:xfrm>
           <a:prstGeom prst="rect">
             <a:avLst/>
@@ -9172,13 +9172,13 @@
             </a:extLst>
           </p:cNvPr>
           <p:cNvSpPr>
-            <a:spLocks noGrp="1"/>
-          </p:cNvSpPr>
-          <p:nvPr/>
-        </p:nvSpPr>
-        <p:spPr>
-          <a:xfrm>
-            <a:off x="9517107" y="4775563"/>
+            <a:spLocks noGrp="1" noChangeAspect="1"/>
+          </p:cNvSpPr>
+          <p:nvPr/>
+        </p:nvSpPr>
+        <p:spPr>
+          <a:xfrm>
+            <a:off x="9517107" y="4775561"/>
             <a:ext cx="228600" cy="228600"/>
           </a:xfrm>
           <a:prstGeom prst="rect">
@@ -9222,13 +9222,13 @@
             </a:extLst>
           </p:cNvPr>
           <p:cNvSpPr>
-            <a:spLocks noGrp="1"/>
-          </p:cNvSpPr>
-          <p:nvPr/>
-        </p:nvSpPr>
-        <p:spPr>
-          <a:xfrm>
-            <a:off x="6383382" y="1651363"/>
+            <a:spLocks noGrp="1" noChangeAspect="1"/>
+          </p:cNvSpPr>
+          <p:nvPr/>
+        </p:nvSpPr>
+        <p:spPr>
+          <a:xfrm>
+            <a:off x="6383382" y="1651360"/>
             <a:ext cx="3543300" cy="3543300"/>
           </a:xfrm>
           <a:custGeom>
@@ -9274,13 +9274,13 @@
             </a:extLst>
           </p:cNvPr>
           <p:cNvSpPr>
-            <a:spLocks noGrp="1"/>
+            <a:spLocks noGrp="1" noChangeAspect="1"/>
           </p:cNvSpPr>
           <p:nvPr/>
         </p:nvSpPr>
         <p:spPr>
           <a:xfrm rot="-5400000">
-            <a:off x="5303794" y="3209798"/>
+            <a:off x="5303792" y="3209798"/>
             <a:ext cx="1238250" cy="228600"/>
           </a:xfrm>
           <a:prstGeom prst="rect">
@@ -9324,14 +9324,14 @@
             </a:extLst>
           </p:cNvPr>
           <p:cNvSpPr>
-            <a:spLocks noGrp="1"/>
-          </p:cNvSpPr>
-          <p:nvPr/>
-        </p:nvSpPr>
-        <p:spPr>
-          <a:xfrm>
-            <a:off x="7507332" y="5623288"/>
-            <a:ext cx="2476500" cy="247650"/>
+            <a:spLocks noGrp="1" noChangeAspect="1"/>
+          </p:cNvSpPr>
+          <p:nvPr/>
+        </p:nvSpPr>
+        <p:spPr>
+          <a:xfrm>
+            <a:off x="7507332" y="5623286"/>
+            <a:ext cx="2476500" cy="247652"/>
           </a:xfrm>
           <a:prstGeom prst="rect">
             <a:avLst/>
@@ -9374,13 +9374,13 @@
             </a:extLst>
           </p:cNvPr>
           <p:cNvSpPr>
-            <a:spLocks noGrp="1"/>
-          </p:cNvSpPr>
-          <p:nvPr/>
-        </p:nvSpPr>
-        <p:spPr>
-          <a:xfrm>
-            <a:off x="6383382" y="1651363"/>
+            <a:spLocks noGrp="1" noChangeAspect="1"/>
+          </p:cNvSpPr>
+          <p:nvPr/>
+        </p:nvSpPr>
+        <p:spPr>
+          <a:xfrm>
+            <a:off x="6383382" y="1651360"/>
             <a:ext cx="3543300" cy="3543300"/>
           </a:xfrm>
           <a:prstGeom prst="rect">
@@ -9412,14 +9412,14 @@
             </a:extLst>
           </p:cNvPr>
           <p:cNvSpPr>
-            <a:spLocks noGrp="1"/>
-          </p:cNvSpPr>
-          <p:nvPr/>
-        </p:nvSpPr>
-        <p:spPr>
-          <a:xfrm>
-            <a:off x="10193382" y="4775563"/>
-            <a:ext cx="209550" cy="390525"/>
+            <a:spLocks noGrp="1" noChangeAspect="1"/>
+          </p:cNvSpPr>
+          <p:nvPr/>
+        </p:nvSpPr>
+        <p:spPr>
+          <a:xfrm>
+            <a:off x="10193382" y="4775560"/>
+            <a:ext cx="209550" cy="390524"/>
           </a:xfrm>
           <a:prstGeom prst="rect">
             <a:avLst/>
@@ -9450,14 +9450,14 @@
             </a:extLst>
           </p:cNvPr>
           <p:cNvSpPr>
-            <a:spLocks noGrp="1"/>
-          </p:cNvSpPr>
-          <p:nvPr/>
-        </p:nvSpPr>
-        <p:spPr>
-          <a:xfrm>
-            <a:off x="10193382" y="4385038"/>
-            <a:ext cx="209550" cy="390525"/>
+            <a:spLocks noGrp="1" noChangeAspect="1"/>
+          </p:cNvSpPr>
+          <p:nvPr/>
+        </p:nvSpPr>
+        <p:spPr>
+          <a:xfrm>
+            <a:off x="10193382" y="4385035"/>
+            <a:ext cx="209550" cy="390524"/>
           </a:xfrm>
           <a:prstGeom prst="rect">
             <a:avLst/>
@@ -9488,14 +9488,14 @@
             </a:extLst>
           </p:cNvPr>
           <p:cNvSpPr>
-            <a:spLocks noGrp="1"/>
-          </p:cNvSpPr>
-          <p:nvPr/>
-        </p:nvSpPr>
-        <p:spPr>
-          <a:xfrm>
-            <a:off x="10193382" y="3994513"/>
-            <a:ext cx="209550" cy="390525"/>
+            <a:spLocks noGrp="1" noChangeAspect="1"/>
+          </p:cNvSpPr>
+          <p:nvPr/>
+        </p:nvSpPr>
+        <p:spPr>
+          <a:xfrm>
+            <a:off x="10193382" y="3994510"/>
+            <a:ext cx="209550" cy="390524"/>
           </a:xfrm>
           <a:prstGeom prst="rect">
             <a:avLst/>
@@ -9526,14 +9526,14 @@
             </a:extLst>
           </p:cNvPr>
           <p:cNvSpPr>
-            <a:spLocks noGrp="1"/>
-          </p:cNvSpPr>
-          <p:nvPr/>
-        </p:nvSpPr>
-        <p:spPr>
-          <a:xfrm>
-            <a:off x="10193382" y="3603988"/>
-            <a:ext cx="209550" cy="390525"/>
+            <a:spLocks noGrp="1" noChangeAspect="1"/>
+          </p:cNvSpPr>
+          <p:nvPr/>
+        </p:nvSpPr>
+        <p:spPr>
+          <a:xfrm>
+            <a:off x="10193382" y="3603985"/>
+            <a:ext cx="209550" cy="390524"/>
           </a:xfrm>
           <a:prstGeom prst="rect">
             <a:avLst/>
@@ -9564,14 +9564,14 @@
             </a:extLst>
           </p:cNvPr>
           <p:cNvSpPr>
-            <a:spLocks noGrp="1"/>
-          </p:cNvSpPr>
-          <p:nvPr/>
-        </p:nvSpPr>
-        <p:spPr>
-          <a:xfrm>
-            <a:off x="10193382" y="3213463"/>
-            <a:ext cx="209550" cy="390525"/>
+            <a:spLocks noGrp="1" noChangeAspect="1"/>
+          </p:cNvSpPr>
+          <p:nvPr/>
+        </p:nvSpPr>
+        <p:spPr>
+          <a:xfrm>
+            <a:off x="10193382" y="3213460"/>
+            <a:ext cx="209550" cy="390524"/>
           </a:xfrm>
           <a:prstGeom prst="rect">
             <a:avLst/>
@@ -9602,14 +9602,14 @@
             </a:extLst>
           </p:cNvPr>
           <p:cNvSpPr>
-            <a:spLocks noGrp="1"/>
-          </p:cNvSpPr>
-          <p:nvPr/>
-        </p:nvSpPr>
-        <p:spPr>
-          <a:xfrm>
-            <a:off x="10193382" y="2822938"/>
-            <a:ext cx="209550" cy="390525"/>
+            <a:spLocks noGrp="1" noChangeAspect="1"/>
+          </p:cNvSpPr>
+          <p:nvPr/>
+        </p:nvSpPr>
+        <p:spPr>
+          <a:xfrm>
+            <a:off x="10193382" y="2822935"/>
+            <a:ext cx="209550" cy="390524"/>
           </a:xfrm>
           <a:prstGeom prst="rect">
             <a:avLst/>
@@ -9640,14 +9640,14 @@
             </a:extLst>
           </p:cNvPr>
           <p:cNvSpPr>
-            <a:spLocks noGrp="1"/>
-          </p:cNvSpPr>
-          <p:nvPr/>
-        </p:nvSpPr>
-        <p:spPr>
-          <a:xfrm>
-            <a:off x="10193382" y="2432413"/>
-            <a:ext cx="209550" cy="390525"/>
+            <a:spLocks noGrp="1" noChangeAspect="1"/>
+          </p:cNvSpPr>
+          <p:nvPr/>
+        </p:nvSpPr>
+        <p:spPr>
+          <a:xfrm>
+            <a:off x="10193382" y="2432410"/>
+            <a:ext cx="209550" cy="390524"/>
           </a:xfrm>
           <a:prstGeom prst="rect">
             <a:avLst/>
@@ -9678,14 +9678,14 @@
             </a:extLst>
           </p:cNvPr>
           <p:cNvSpPr>
-            <a:spLocks noGrp="1"/>
-          </p:cNvSpPr>
-          <p:nvPr/>
-        </p:nvSpPr>
-        <p:spPr>
-          <a:xfrm>
-            <a:off x="10193382" y="2041888"/>
-            <a:ext cx="209550" cy="390525"/>
+            <a:spLocks noGrp="1" noChangeAspect="1"/>
+          </p:cNvSpPr>
+          <p:nvPr/>
+        </p:nvSpPr>
+        <p:spPr>
+          <a:xfrm>
+            <a:off x="10193382" y="2041885"/>
+            <a:ext cx="209550" cy="390524"/>
           </a:xfrm>
           <a:prstGeom prst="rect">
             <a:avLst/>
@@ -9716,14 +9716,14 @@
             </a:extLst>
           </p:cNvPr>
           <p:cNvSpPr>
-            <a:spLocks noGrp="1"/>
-          </p:cNvSpPr>
-          <p:nvPr/>
-        </p:nvSpPr>
-        <p:spPr>
-          <a:xfrm>
-            <a:off x="10193382" y="1651363"/>
-            <a:ext cx="209550" cy="390525"/>
+            <a:spLocks noGrp="1" noChangeAspect="1"/>
+          </p:cNvSpPr>
+          <p:nvPr/>
+        </p:nvSpPr>
+        <p:spPr>
+          <a:xfrm>
+            <a:off x="10193382" y="1651360"/>
+            <a:ext cx="209550" cy="390524"/>
           </a:xfrm>
           <a:prstGeom prst="rect">
             <a:avLst/>
@@ -9754,13 +9754,13 @@
             </a:extLst>
           </p:cNvPr>
           <p:cNvSpPr>
-            <a:spLocks noGrp="1"/>
-          </p:cNvSpPr>
-          <p:nvPr/>
-        </p:nvSpPr>
-        <p:spPr>
-          <a:xfrm>
-            <a:off x="10193382" y="1651363"/>
+            <a:spLocks noGrp="1" noChangeAspect="1"/>
+          </p:cNvSpPr>
+          <p:nvPr/>
+        </p:nvSpPr>
+        <p:spPr>
+          <a:xfrm>
+            <a:off x="10193382" y="1651361"/>
             <a:ext cx="209550" cy="3514725"/>
           </a:xfrm>
           <a:prstGeom prst="rect">
@@ -9792,13 +9792,13 @@
             </a:extLst>
           </p:cNvPr>
           <p:cNvSpPr>
-            <a:spLocks noGrp="1"/>
+            <a:spLocks noGrp="1" noChangeAspect="1"/>
           </p:cNvSpPr>
           <p:nvPr/>
         </p:nvSpPr>
         <p:spPr>
           <a:xfrm rot="-5400000">
-            <a:off x="10422526" y="3127738"/>
+            <a:off x="10422524" y="3127738"/>
             <a:ext cx="1238250" cy="228600"/>
           </a:xfrm>
           <a:prstGeom prst="rect">

</xml_diff>